<commit_message>
Remove menções a patins no manual (foco em skate) e regenera PPTX/PDF
Ajusta o conteúdo da página do manual e o gerador build-manual.js para
falar apenas de skate, com correção gramatical nas frases afetadas
(segurança, título de valores, mensagem final e subtítulo da capa), e
regenera o folheto Manual-Loop-2026.pptx/.pdf.

Co-Authored-By: Claude Opus 4.8 <noreply@anthropic.com>
Claude-Session: https://claude.ai/code/session_01VssgEjhykxBp7XR9VnGHUg
</commit_message>
<xml_diff>
--- a/manual-dos-alunos-e-responsaveis/Manual-Loop-2026.pptx
+++ b/manual-dos-alunos-e-responsaveis/Manual-Loop-2026.pptx
@@ -2835,7 +2835,7 @@
       </p:grpSpPr>
       <p:pic>
         <p:nvPicPr>
-          <p:cNvPr id="2" name="Image 0" descr="/tmp/claude-0/-home-user-alessandra-loop-github-io/f5b4df79-872a-59ff-bf8b-a58b030e82c9/scratchpad/logo-loop.png">    </p:cNvPr>
+          <p:cNvPr id="2" name="Image 0" descr="preencoded.png">    </p:cNvPr>
           <p:cNvPicPr>
             <a:picLocks noChangeAspect="1"/>
           </p:cNvPicPr>
@@ -3013,7 +3013,7 @@
                 <a:ea typeface="Oswald" pitchFamily="34" charset="-122"/>
                 <a:cs typeface="Oswald" pitchFamily="34" charset="-120"/>
               </a:rPr>
-              <a:t>Escola de skate e patins • Belo Horizonte / MG</a:t>
+              <a:t>Escola de skate • Belo Horizonte / MG</a:t>
             </a:r>
             <a:endParaRPr lang="en-US" sz="1200" dirty="0"/>
           </a:p>
@@ -4568,7 +4568,7 @@
                 <a:ea typeface="Barlow" pitchFamily="34" charset="-122"/>
                 <a:cs typeface="Barlow" pitchFamily="34" charset="-120"/>
               </a:rPr>
-              <a:t>Ensinar segurança no skate e patins é ensinar responsabilidade, percepção de risco e cuidado consigo e com o outro.</a:t>
+              <a:t>Ensinar segurança no skate é ensinar responsabilidade, percepção de risco e cuidado consigo e com o outro.</a:t>
             </a:r>
             <a:endParaRPr lang="en-US" sz="1250" dirty="0"/>
           </a:p>
@@ -10255,7 +10255,7 @@
                 <a:ea typeface="Anton" pitchFamily="34" charset="-122"/>
                 <a:cs typeface="Anton" pitchFamily="34" charset="-120"/>
               </a:rPr>
-              <a:t>VALORES QUE O SKATE E PATINS ENSINAM</a:t>
+              <a:t>VALORES QUE O SKATE ENSINA</a:t>
             </a:r>
             <a:endParaRPr lang="en-US" sz="2900" dirty="0"/>
           </a:p>
@@ -14428,7 +14428,7 @@
                 <a:ea typeface="Barlow" pitchFamily="34" charset="-122"/>
                 <a:cs typeface="Barlow" pitchFamily="34" charset="-120"/>
               </a:rPr>
-              <a:t>Skate e patins não são apenas sobre manobras. É sobre experimentar, persistir, cair, levantar e aprender.</a:t>
+              <a:t>O skate não é apenas sobre manobras. É sobre experimentar, persistir, cair, levantar e aprender.</a:t>
             </a:r>
             <a:endParaRPr lang="en-US" sz="1600" dirty="0"/>
           </a:p>
@@ -14478,7 +14478,7 @@
       </p:sp>
       <p:pic>
         <p:nvPicPr>
-          <p:cNvPr id="5" name="Image 0" descr="/tmp/claude-0/-home-user-alessandra-loop-github-io/f5b4df79-872a-59ff-bf8b-a58b030e82c9/scratchpad/logo-loop.png">    </p:cNvPr>
+          <p:cNvPr id="5" name="Image 0" descr="preencoded.png">    </p:cNvPr>
           <p:cNvPicPr>
             <a:picLocks noChangeAspect="1"/>
           </p:cNvPicPr>
@@ -15102,7 +15102,7 @@
       </p:grpSpPr>
       <p:pic>
         <p:nvPicPr>
-          <p:cNvPr id="2" name="Image 0" descr="/tmp/claude-0/-home-user-alessandra-loop-github-io/f5b4df79-872a-59ff-bf8b-a58b030e82c9/scratchpad/logo-loop.png">    </p:cNvPr>
+          <p:cNvPr id="2" name="Image 0" descr="preencoded.png">    </p:cNvPr>
           <p:cNvPicPr>
             <a:picLocks noChangeAspect="1"/>
           </p:cNvPicPr>

</xml_diff>